<commit_message>
feat: add network-ready routing handoff
</commit_message>
<xml_diff>
--- a/docs/presentations/routing-integration/外部路由系统对接讲解.pptx
+++ b/docs/presentations/routing-integration/外部路由系统对接讲解.pptx
@@ -1924,7 +1924,7 @@
                 <a:ea typeface="Microsoft YaHei" pitchFamily="34" charset="-122"/>
                 <a:cs typeface="Microsoft YaHei" pitchFamily="34" charset="-120"/>
               </a:rPr>
-              <a:t>扫表领取工单 → 计算 placements → 回写部署位置 → 消费资源释放事件</a:t>
+              <a:t>扫表领取工单 → 回写 placements → 获取端口绑定 → network-ready → 释放事件</a:t>
             </a:r>
             <a:endParaRPr lang="en-US" sz="1500" dirty="0"/>
           </a:p>
@@ -3113,7 +3113,7 @@
                 <a:ea typeface="Microsoft YaHei" pitchFamily="34" charset="-122"/>
                 <a:cs typeface="Microsoft YaHei" pitchFamily="34" charset="-120"/>
               </a:rPr>
-              <a:t>带 X-Service-Token</a:t>
+              <a:t>无 token；result 返回 bindings</a:t>
             </a:r>
             <a:endParaRPr lang="en-US" sz="760" dirty="0"/>
           </a:p>
@@ -3217,7 +3217,7 @@
                 <a:ea typeface="Microsoft YaHei" pitchFamily="34" charset="-122"/>
                 <a:cs typeface="Microsoft YaHei" pitchFamily="34" charset="-120"/>
               </a:rPr>
-              <a:t>第一步：平台创建 3 个 pending 工单，路由系统 claim 后回写 placements。</a:t>
+              <a:t>第一步：平台创建 3 个 pending 工单，路由系统 claim 后回写 placements，并读取 network_bindings。</a:t>
             </a:r>
             <a:endParaRPr lang="en-US" sz="1050" dirty="0"/>
           </a:p>
@@ -3231,7 +3231,7 @@
                 <a:ea typeface="Microsoft YaHei" pitchFamily="34" charset="-122"/>
                 <a:cs typeface="Microsoft YaHei" pitchFamily="34" charset="-120"/>
               </a:rPr>
-              <a:t>第二步：平台页面确认工单进入部署流程，能看到 compute 节点和 GPU 编号。</a:t>
+              <a:t>第二步：路由系统下发网络规则并调用 network-ready，平台页面能看到 compute/GPU。</a:t>
             </a:r>
             <a:endParaRPr lang="en-US" sz="1050" dirty="0"/>
           </a:p>
@@ -5699,7 +5699,7 @@
                 <a:ea typeface="Microsoft YaHei" pitchFamily="34" charset="-122"/>
                 <a:cs typeface="Microsoft YaHei" pitchFamily="34" charset="-120"/>
               </a:rPr>
-              <a:t>扫表可以简单，但 claim / requeue / fail / result 需要明确。</a:t>
+              <a:t>扫表可以简单，但 claim / requeue / fail / result / network-ready 需要明确。</a:t>
             </a:r>
             <a:endParaRPr lang="en-US" sz="1050" dirty="0"/>
           </a:p>
@@ -5903,7 +5903,7 @@
                 <a:ea typeface="Microsoft YaHei" pitchFamily="34" charset="-122"/>
                 <a:cs typeface="Microsoft YaHei" pitchFamily="34" charset="-120"/>
               </a:rPr>
-              <a:t>completed</a:t>
+              <a:t>network_binding_ready / completed</a:t>
             </a:r>
             <a:endParaRPr lang="en-US" sz="1200" dirty="0"/>
           </a:p>
@@ -6485,7 +6485,7 @@
                 <a:ea typeface="Microsoft YaHei" pitchFamily="34" charset="-122"/>
                 <a:cs typeface="Microsoft YaHei" pitchFamily="34" charset="-120"/>
               </a:rPr>
-              <a:t>pending → computing 必须原子抢占；资源暂不足用 requeue。</a:t>
+              <a:t>pending → computing 必须原子抢占；result 后等待 network-ready；资源暂不足用 requeue。</a:t>
             </a:r>
             <a:endParaRPr lang="en-US" sz="920" dirty="0"/>
           </a:p>
@@ -6623,7 +6623,7 @@
                 <a:ea typeface="Microsoft YaHei" pitchFamily="34" charset="-122"/>
                 <a:cs typeface="Microsoft YaHei" pitchFamily="34" charset="-120"/>
               </a:rPr>
-              <a:t>接收 result 时校验 GPU 冲突；已占用则返回 409。</a:t>
+              <a:t>接收 result 时校验 GPU 冲突并返回 network_bindings；已占用则返回 409。</a:t>
             </a:r>
             <a:endParaRPr lang="en-US" sz="920" dirty="0"/>
           </a:p>
@@ -7142,7 +7142,7 @@
                 <a:ea typeface="Microsoft YaHei" pitchFamily="34" charset="-122"/>
                 <a:cs typeface="Microsoft YaHei" pitchFamily="34" charset="-120"/>
               </a:rPr>
-              <a:t>数据库用于发现任务；HTTP 用于状态变更、结果回写和审计。</a:t>
+              <a:t>数据库用于发现任务；HTTP 用于状态变更、端口绑定返回、network-ready 和审计。</a:t>
             </a:r>
             <a:endParaRPr lang="en-US" sz="1050" dirty="0"/>
           </a:p>
@@ -7921,7 +7921,7 @@
                 <a:ea typeface="Microsoft YaHei" pitchFamily="34" charset="-122"/>
                 <a:cs typeface="Microsoft YaHei" pitchFamily="34" charset="-120"/>
               </a:rPr>
-              <a:t>物化实例</a:t>
+              <a:t>物化实例/动态端口</a:t>
             </a:r>
             <a:endParaRPr lang="en-US" sz="820" dirty="0"/>
           </a:p>
@@ -7989,7 +7989,7 @@
                 <a:ea typeface="Microsoft YaHei" pitchFamily="34" charset="-122"/>
                 <a:cs typeface="Microsoft YaHei" pitchFamily="34" charset="-120"/>
               </a:rPr>
-              <a:t>容器运行</a:t>
+              <a:t>network-ready 后运行</a:t>
             </a:r>
             <a:endParaRPr lang="en-US" sz="820" dirty="0"/>
           </a:p>
@@ -8218,7 +8218,7 @@
                 <a:ea typeface="Microsoft YaHei" pitchFamily="34" charset="-122"/>
                 <a:cs typeface="Microsoft YaHei" pitchFamily="34" charset="-120"/>
               </a:rPr>
-              <a:t>前端选择“外部路由系统”时，平台只创建 pending 工单；路由回写 placements 后平台自动部署。</a:t>
+              <a:t>前端选择“外部路由系统”时，平台只创建 pending 工单；路由回写 placements 后返回 network_bindings，路由下发网络并调用 network-ready 后平台启动。</a:t>
             </a:r>
             <a:endParaRPr lang="en-US" sz="1000" dirty="0"/>
           </a:p>
@@ -9057,7 +9057,7 @@
                 <a:ea typeface="Microsoft YaHei" pitchFamily="34" charset="-122"/>
                 <a:cs typeface="Microsoft YaHei" pitchFamily="34" charset="-120"/>
               </a:rPr>
-              <a:t>输出：POST result</a:t>
+              <a:t>输出：POST result + network-ready</a:t>
             </a:r>
             <a:endParaRPr lang="en-US" sz="750" dirty="0"/>
           </a:p>
@@ -12057,36 +12057,36 @@
 </file>
 
 <file path=ppt/slides/slide9.xml><?xml version="1.0" encoding="utf-8"?>
-<p:sld xmlns:a="http://schemas.openxmlformats.org/drawingml/2006/main" xmlns:r="http://schemas.openxmlformats.org/officeDocument/2006/relationships" xmlns:p="http://schemas.openxmlformats.org/presentationml/2006/main">
-  <p:cSld name="Slide 9">
-    <p:bg>
-      <p:bgPr>
+<ns0:sld xmlns:a="http://schemas.openxmlformats.org/drawingml/2006/main" xmlns:ns0="http://schemas.openxmlformats.org/presentationml/2006/main">
+  <ns0:cSld name="Slide 9">
+    <ns0:bg>
+      <ns0:bgPr>
         <a:solidFill>
           <a:srgbClr val="071827"/>
         </a:solidFill>
-      </p:bgPr>
-    </p:bg>
-    <p:spTree>
-      <p:nvGrpSpPr>
-        <p:cNvPr id="1" name=""/>
-        <p:cNvGrpSpPr/>
-        <p:nvPr/>
-      </p:nvGrpSpPr>
-      <p:grpSpPr>
+      </ns0:bgPr>
+    </ns0:bg>
+    <ns0:spTree>
+      <ns0:nvGrpSpPr>
+        <ns0:cNvPr id="1" name=""/>
+        <ns0:cNvGrpSpPr/>
+        <ns0:nvPr/>
+      </ns0:nvGrpSpPr>
+      <ns0:grpSpPr>
         <a:xfrm>
           <a:off x="0" y="0"/>
           <a:ext cx="0" cy="0"/>
           <a:chOff x="0" y="0"/>
           <a:chExt cx="0" cy="0"/>
         </a:xfrm>
-      </p:grpSpPr>
-      <p:sp>
-        <p:nvSpPr>
-          <p:cNvPr id="2" name="Shape 0"/>
-          <p:cNvSpPr/>
-          <p:nvPr/>
-        </p:nvSpPr>
-        <p:spPr>
+      </ns0:grpSpPr>
+      <ns0:sp>
+        <ns0:nvSpPr>
+          <ns0:cNvPr id="2" name="Shape 0"/>
+          <ns0:cNvSpPr/>
+          <ns0:nvPr/>
+        </ns0:nvSpPr>
+        <ns0:spPr>
           <a:xfrm>
             <a:off x="0" y="0"/>
             <a:ext cx="12191695" cy="6858000"/>
@@ -12103,15 +12103,15 @@
             </a:solidFill>
             <a:prstDash val="solid"/>
           </a:ln>
-        </p:spPr>
-      </p:sp>
-      <p:sp>
-        <p:nvSpPr>
-          <p:cNvPr id="3" name="Shape 1"/>
-          <p:cNvSpPr/>
-          <p:nvPr/>
-        </p:nvSpPr>
-        <p:spPr>
+        </ns0:spPr>
+      </ns0:sp>
+      <ns0:sp>
+        <ns0:nvSpPr>
+          <ns0:cNvPr id="3" name="Shape 1"/>
+          <ns0:cNvSpPr/>
+          <ns0:nvPr/>
+        </ns0:nvSpPr>
+        <ns0:spPr>
           <a:xfrm>
             <a:off x="9646920" y="-914400"/>
             <a:ext cx="3566160" cy="3566160"/>
@@ -12128,15 +12128,15 @@
             </a:solidFill>
             <a:prstDash val="solid"/>
           </a:ln>
-        </p:spPr>
-      </p:sp>
-      <p:sp>
-        <p:nvSpPr>
-          <p:cNvPr id="4" name="Shape 2"/>
-          <p:cNvSpPr/>
-          <p:nvPr/>
-        </p:nvSpPr>
-        <p:spPr>
+        </ns0:spPr>
+      </ns0:sp>
+      <ns0:sp>
+        <ns0:nvSpPr>
+          <ns0:cNvPr id="4" name="Shape 2"/>
+          <ns0:cNvSpPr/>
+          <ns0:nvPr/>
+        </ns0:nvSpPr>
+        <ns0:spPr>
           <a:xfrm>
             <a:off x="-1645920" y="5303520"/>
             <a:ext cx="3291840" cy="3291840"/>
@@ -12153,15 +12153,15 @@
             </a:solidFill>
             <a:prstDash val="solid"/>
           </a:ln>
-        </p:spPr>
-      </p:sp>
-      <p:sp>
-        <p:nvSpPr>
-          <p:cNvPr id="5" name="Shape 3"/>
-          <p:cNvSpPr/>
-          <p:nvPr/>
-        </p:nvSpPr>
-        <p:spPr>
+        </ns0:spPr>
+      </ns0:sp>
+      <ns0:sp>
+        <ns0:nvSpPr>
+          <ns0:cNvPr id="5" name="Shape 3"/>
+          <ns0:cNvSpPr/>
+          <ns0:nvPr/>
+        </ns0:nvSpPr>
+        <ns0:spPr>
           <a:xfrm>
             <a:off x="0" y="0"/>
             <a:ext cx="109728" cy="6858000"/>
@@ -12178,15 +12178,15 @@
             </a:solidFill>
             <a:prstDash val="solid"/>
           </a:ln>
-        </p:spPr>
-      </p:sp>
-      <p:sp>
-        <p:nvSpPr>
-          <p:cNvPr id="6" name="Text 4"/>
-          <p:cNvSpPr/>
-          <p:nvPr/>
-        </p:nvSpPr>
-        <p:spPr>
+        </ns0:spPr>
+      </ns0:sp>
+      <ns0:sp>
+        <ns0:nvSpPr>
+          <ns0:cNvPr id="6" name="Text 4"/>
+          <ns0:cNvSpPr/>
+          <ns0:nvPr/>
+        </ns0:nvSpPr>
+        <ns0:spPr>
           <a:xfrm>
             <a:off x="502920" y="228600"/>
             <a:ext cx="5029200" cy="228600"/>
@@ -12196,8 +12196,8 @@
           </a:prstGeom>
           <a:noFill/>
           <a:ln/>
-        </p:spPr>
-        <p:txBody>
+        </ns0:spPr>
+        <ns0:txBody>
           <a:bodyPr wrap="square" lIns="0" tIns="0" rIns="0" bIns="0" rtlCol="0" anchor="ctr"/>
           <a:lstStyle/>
           <a:p>
@@ -12217,15 +12217,15 @@
             </a:r>
             <a:endParaRPr lang="en-US" sz="850" dirty="0"/>
           </a:p>
-        </p:txBody>
-      </p:sp>
-      <p:sp>
-        <p:nvSpPr>
-          <p:cNvPr id="7" name="Shape 5"/>
-          <p:cNvSpPr/>
-          <p:nvPr/>
-        </p:nvSpPr>
-        <p:spPr>
+        </ns0:txBody>
+      </ns0:sp>
+      <ns0:sp>
+        <ns0:nvSpPr>
+          <ns0:cNvPr id="7" name="Shape 5"/>
+          <ns0:cNvSpPr/>
+          <ns0:nvPr/>
+        </ns0:nvSpPr>
+        <ns0:spPr>
           <a:xfrm>
             <a:off x="502920" y="6446520"/>
             <a:ext cx="10744200" cy="0"/>
@@ -12242,15 +12242,15 @@
             </a:solidFill>
             <a:prstDash val="solid"/>
           </a:ln>
-        </p:spPr>
-      </p:sp>
-      <p:sp>
-        <p:nvSpPr>
-          <p:cNvPr id="8" name="Text 6"/>
-          <p:cNvSpPr/>
-          <p:nvPr/>
-        </p:nvSpPr>
-        <p:spPr>
+        </ns0:spPr>
+      </ns0:sp>
+      <ns0:sp>
+        <ns0:nvSpPr>
+          <ns0:cNvPr id="8" name="Text 6"/>
+          <ns0:cNvSpPr/>
+          <ns0:nvPr/>
+        </ns0:nvSpPr>
+        <ns0:spPr>
           <a:xfrm>
             <a:off x="502920" y="6510528"/>
             <a:ext cx="4572000" cy="201168"/>
@@ -12260,8 +12260,8 @@
           </a:prstGeom>
           <a:noFill/>
           <a:ln/>
-        </p:spPr>
-        <p:txBody>
+        </ns0:spPr>
+        <ns0:txBody>
           <a:bodyPr wrap="square" lIns="0" tIns="0" rIns="0" bIns="0" rtlCol="0" anchor="ctr"/>
           <a:lstStyle/>
           <a:p>
@@ -12281,15 +12281,15 @@
             </a:r>
             <a:endParaRPr lang="en-US" sz="750" dirty="0"/>
           </a:p>
-        </p:txBody>
-      </p:sp>
-      <p:sp>
-        <p:nvSpPr>
-          <p:cNvPr id="9" name="Shape 7"/>
-          <p:cNvSpPr/>
-          <p:nvPr/>
-        </p:nvSpPr>
-        <p:spPr>
+        </ns0:txBody>
+      </ns0:sp>
+      <ns0:sp>
+        <ns0:nvSpPr>
+          <ns0:cNvPr id="9" name="Shape 7"/>
+          <ns0:cNvSpPr/>
+          <ns0:nvPr/>
+        </ns0:nvSpPr>
+        <ns0:spPr>
           <a:xfrm>
             <a:off x="11292840" y="6419088"/>
             <a:ext cx="411480" cy="292608"/>
@@ -12310,15 +12310,15 @@
             </a:solidFill>
             <a:prstDash val="solid"/>
           </a:ln>
-        </p:spPr>
-      </p:sp>
-      <p:sp>
-        <p:nvSpPr>
-          <p:cNvPr id="10" name="Text 8"/>
-          <p:cNvSpPr/>
-          <p:nvPr/>
-        </p:nvSpPr>
-        <p:spPr>
+        </ns0:spPr>
+      </ns0:sp>
+      <ns0:sp>
+        <ns0:nvSpPr>
+          <ns0:cNvPr id="10" name="Text 8"/>
+          <ns0:cNvSpPr/>
+          <ns0:nvPr/>
+        </ns0:nvSpPr>
+        <ns0:spPr>
           <a:xfrm>
             <a:off x="11292840" y="6464808"/>
             <a:ext cx="411480" cy="182880"/>
@@ -12328,8 +12328,8 @@
           </a:prstGeom>
           <a:noFill/>
           <a:ln/>
-        </p:spPr>
-        <p:txBody>
+        </ns0:spPr>
+        <ns0:txBody>
           <a:bodyPr wrap="square" lIns="0" tIns="0" rIns="0" bIns="0" rtlCol="0" anchor="ctr"/>
           <a:lstStyle/>
           <a:p>
@@ -12349,15 +12349,15 @@
             </a:r>
             <a:endParaRPr lang="en-US" sz="850" dirty="0"/>
           </a:p>
-        </p:txBody>
-      </p:sp>
-      <p:sp>
-        <p:nvSpPr>
-          <p:cNvPr id="11" name="Text 9"/>
-          <p:cNvSpPr/>
-          <p:nvPr/>
-        </p:nvSpPr>
-        <p:spPr>
+        </ns0:txBody>
+      </ns0:sp>
+      <ns0:sp>
+        <ns0:nvSpPr>
+          <ns0:cNvPr id="11" name="Text 9"/>
+          <ns0:cNvSpPr/>
+          <ns0:nvPr/>
+        </ns0:nvSpPr>
+        <ns0:spPr>
           <a:xfrm>
             <a:off x="594360" y="658368"/>
             <a:ext cx="8138160" cy="438912"/>
@@ -12367,8 +12367,8 @@
           </a:prstGeom>
           <a:noFill/>
           <a:ln/>
-        </p:spPr>
-        <p:txBody>
+        </ns0:spPr>
+        <ns0:txBody>
           <a:bodyPr wrap="square" lIns="0" tIns="0" rIns="0" bIns="0" rtlCol="0" anchor="ctr"/>
           <a:lstStyle/>
           <a:p>
@@ -12388,15 +12388,15 @@
             </a:r>
             <a:endParaRPr lang="en-US" sz="2600" dirty="0"/>
           </a:p>
-        </p:txBody>
-      </p:sp>
-      <p:sp>
-        <p:nvSpPr>
-          <p:cNvPr id="12" name="Text 10"/>
-          <p:cNvSpPr/>
-          <p:nvPr/>
-        </p:nvSpPr>
-        <p:spPr>
+        </ns0:txBody>
+      </ns0:sp>
+      <ns0:sp>
+        <ns0:nvSpPr>
+          <ns0:cNvPr id="12" name="Text 10"/>
+          <ns0:cNvSpPr/>
+          <ns0:nvPr/>
+        </ns0:nvSpPr>
+        <ns0:spPr>
           <a:xfrm>
             <a:off x="621792" y="1143000"/>
             <a:ext cx="9875520" cy="292608"/>
@@ -12406,8 +12406,8 @@
           </a:prstGeom>
           <a:noFill/>
           <a:ln/>
-        </p:spPr>
-        <p:txBody>
+        </ns0:spPr>
+        <ns0:txBody>
           <a:bodyPr wrap="square" lIns="0" tIns="0" rIns="0" bIns="0" rtlCol="0" anchor="ctr"/>
           <a:lstStyle/>
           <a:p>
@@ -12427,15 +12427,15 @@
             </a:r>
             <a:endParaRPr lang="en-US" sz="1050" dirty="0"/>
           </a:p>
-        </p:txBody>
-      </p:sp>
-      <p:sp>
-        <p:nvSpPr>
-          <p:cNvPr id="13" name="Shape 11"/>
-          <p:cNvSpPr/>
-          <p:nvPr/>
-        </p:nvSpPr>
-        <p:spPr>
+        </ns0:txBody>
+      </ns0:sp>
+      <ns0:sp>
+        <ns0:nvSpPr>
+          <ns0:cNvPr id="13" name="Shape 11"/>
+          <ns0:cNvSpPr/>
+          <ns0:nvPr/>
+        </ns0:nvSpPr>
+        <ns0:spPr>
           <a:xfrm>
             <a:off x="713232" y="1609344"/>
             <a:ext cx="10771632" cy="4389120"/>
@@ -12456,15 +12456,15 @@
             </a:solidFill>
             <a:prstDash val="solid"/>
           </a:ln>
-        </p:spPr>
-      </p:sp>
-      <p:sp>
-        <p:nvSpPr>
-          <p:cNvPr id="14" name="Shape 12"/>
-          <p:cNvSpPr/>
-          <p:nvPr/>
-        </p:nvSpPr>
-        <p:spPr>
+        </ns0:spPr>
+      </ns0:sp>
+      <ns0:sp>
+        <ns0:nvSpPr>
+          <ns0:cNvPr id="14" name="Shape 12"/>
+          <ns0:cNvSpPr/>
+          <ns0:nvPr/>
+        </ns0:nvSpPr>
+        <ns0:spPr>
           <a:xfrm>
             <a:off x="987552" y="1920240"/>
             <a:ext cx="384048" cy="384048"/>
@@ -12481,15 +12481,15 @@
             </a:solidFill>
             <a:prstDash val="solid"/>
           </a:ln>
-        </p:spPr>
-      </p:sp>
-      <p:sp>
-        <p:nvSpPr>
-          <p:cNvPr id="15" name="Text 13"/>
-          <p:cNvSpPr/>
-          <p:nvPr/>
-        </p:nvSpPr>
-        <p:spPr>
+        </ns0:spPr>
+      </ns0:sp>
+      <ns0:sp>
+        <ns0:nvSpPr>
+          <ns0:cNvPr id="15" name="Text 13"/>
+          <ns0:cNvSpPr/>
+          <ns0:nvPr/>
+        </ns0:nvSpPr>
+        <ns0:spPr>
           <a:xfrm>
             <a:off x="987552" y="1993392"/>
             <a:ext cx="384048" cy="128016"/>
@@ -12499,8 +12499,8 @@
           </a:prstGeom>
           <a:noFill/>
           <a:ln/>
-        </p:spPr>
-        <p:txBody>
+        </ns0:spPr>
+        <ns0:txBody>
           <a:bodyPr wrap="square" lIns="0" tIns="0" rIns="0" bIns="0" rtlCol="0" anchor="ctr"/>
           <a:lstStyle/>
           <a:p>
@@ -12520,15 +12520,15 @@
             </a:r>
             <a:endParaRPr lang="en-US" sz="840" dirty="0"/>
           </a:p>
-        </p:txBody>
-      </p:sp>
-      <p:sp>
-        <p:nvSpPr>
-          <p:cNvPr id="16" name="Text 14"/>
-          <p:cNvSpPr/>
-          <p:nvPr/>
-        </p:nvSpPr>
-        <p:spPr>
+        </ns0:txBody>
+      </ns0:sp>
+      <ns0:sp>
+        <ns0:nvSpPr>
+          <ns0:cNvPr id="16" name="Text 14"/>
+          <ns0:cNvSpPr/>
+          <ns0:nvPr/>
+        </ns0:nvSpPr>
+        <ns0:spPr>
           <a:xfrm>
             <a:off x="1554480" y="1938528"/>
             <a:ext cx="1280160" cy="182880"/>
@@ -12538,8 +12538,8 @@
           </a:prstGeom>
           <a:noFill/>
           <a:ln/>
-        </p:spPr>
-        <p:txBody>
+        </ns0:spPr>
+        <ns0:txBody>
           <a:bodyPr wrap="square" lIns="0" tIns="0" rIns="0" bIns="0" rtlCol="0" anchor="ctr"/>
           <a:lstStyle/>
           <a:p>
@@ -12559,15 +12559,15 @@
             </a:r>
             <a:endParaRPr lang="en-US" sz="1050" dirty="0"/>
           </a:p>
-        </p:txBody>
-      </p:sp>
-      <p:sp>
-        <p:nvSpPr>
-          <p:cNvPr id="17" name="Text 15"/>
-          <p:cNvSpPr/>
-          <p:nvPr/>
-        </p:nvSpPr>
-        <p:spPr>
+        </ns0:txBody>
+      </ns0:sp>
+      <ns0:sp>
+        <ns0:nvSpPr>
+          <ns0:cNvPr id="17" name="Text 15"/>
+          <ns0:cNvSpPr/>
+          <ns0:nvPr/>
+        </ns0:nvSpPr>
+        <ns0:spPr>
           <a:xfrm>
             <a:off x="2816352" y="1947672"/>
             <a:ext cx="7863840" cy="201168"/>
@@ -12577,8 +12577,8 @@
           </a:prstGeom>
           <a:noFill/>
           <a:ln/>
-        </p:spPr>
-        <p:txBody>
+        </ns0:spPr>
+        <ns0:txBody>
           <a:bodyPr wrap="square" lIns="0" tIns="0" rIns="0" bIns="0" rtlCol="0" anchor="ctr"/>
           <a:lstStyle/>
           <a:p>
@@ -12598,15 +12598,15 @@
             </a:r>
             <a:endParaRPr lang="en-US" sz="960" dirty="0"/>
           </a:p>
-        </p:txBody>
-      </p:sp>
-      <p:sp>
-        <p:nvSpPr>
-          <p:cNvPr id="18" name="Shape 16"/>
-          <p:cNvSpPr/>
-          <p:nvPr/>
-        </p:nvSpPr>
-        <p:spPr>
+        </ns0:txBody>
+      </ns0:sp>
+      <ns0:sp>
+        <ns0:nvSpPr>
+          <ns0:cNvPr id="18" name="Shape 16"/>
+          <ns0:cNvSpPr/>
+          <ns0:nvPr/>
+        </ns0:nvSpPr>
+        <ns0:spPr>
           <a:xfrm>
             <a:off x="987552" y="2487168"/>
             <a:ext cx="384048" cy="384048"/>
@@ -12623,15 +12623,15 @@
             </a:solidFill>
             <a:prstDash val="solid"/>
           </a:ln>
-        </p:spPr>
-      </p:sp>
-      <p:sp>
-        <p:nvSpPr>
-          <p:cNvPr id="19" name="Text 17"/>
-          <p:cNvSpPr/>
-          <p:nvPr/>
-        </p:nvSpPr>
-        <p:spPr>
+        </ns0:spPr>
+      </ns0:sp>
+      <ns0:sp>
+        <ns0:nvSpPr>
+          <ns0:cNvPr id="19" name="Text 17"/>
+          <ns0:cNvSpPr/>
+          <ns0:nvPr/>
+        </ns0:nvSpPr>
+        <ns0:spPr>
           <a:xfrm>
             <a:off x="987552" y="2560320"/>
             <a:ext cx="384048" cy="128016"/>
@@ -12641,8 +12641,8 @@
           </a:prstGeom>
           <a:noFill/>
           <a:ln/>
-        </p:spPr>
-        <p:txBody>
+        </ns0:spPr>
+        <ns0:txBody>
           <a:bodyPr wrap="square" lIns="0" tIns="0" rIns="0" bIns="0" rtlCol="0" anchor="ctr"/>
           <a:lstStyle/>
           <a:p>
@@ -12662,15 +12662,15 @@
             </a:r>
             <a:endParaRPr lang="en-US" sz="840" dirty="0"/>
           </a:p>
-        </p:txBody>
-      </p:sp>
-      <p:sp>
-        <p:nvSpPr>
-          <p:cNvPr id="20" name="Text 18"/>
-          <p:cNvSpPr/>
-          <p:nvPr/>
-        </p:nvSpPr>
-        <p:spPr>
+        </ns0:txBody>
+      </ns0:sp>
+      <ns0:sp>
+        <ns0:nvSpPr>
+          <ns0:cNvPr id="20" name="Text 18"/>
+          <ns0:cNvSpPr/>
+          <ns0:nvPr/>
+        </ns0:nvSpPr>
+        <ns0:spPr>
           <a:xfrm>
             <a:off x="1554480" y="2505456"/>
             <a:ext cx="1280160" cy="182880"/>
@@ -12680,8 +12680,8 @@
           </a:prstGeom>
           <a:noFill/>
           <a:ln/>
-        </p:spPr>
-        <p:txBody>
+        </ns0:spPr>
+        <ns0:txBody>
           <a:bodyPr wrap="square" lIns="0" tIns="0" rIns="0" bIns="0" rtlCol="0" anchor="ctr"/>
           <a:lstStyle/>
           <a:p>
@@ -12701,15 +12701,15 @@
             </a:r>
             <a:endParaRPr lang="en-US" sz="1050" dirty="0"/>
           </a:p>
-        </p:txBody>
-      </p:sp>
-      <p:sp>
-        <p:nvSpPr>
-          <p:cNvPr id="21" name="Text 19"/>
-          <p:cNvSpPr/>
-          <p:nvPr/>
-        </p:nvSpPr>
-        <p:spPr>
+        </ns0:txBody>
+      </ns0:sp>
+      <ns0:sp>
+        <ns0:nvSpPr>
+          <ns0:cNvPr id="21" name="Text 19"/>
+          <ns0:cNvSpPr/>
+          <ns0:nvPr/>
+        </ns0:nvSpPr>
+        <ns0:spPr>
           <a:xfrm>
             <a:off x="2816352" y="2514600"/>
             <a:ext cx="7863840" cy="201168"/>
@@ -12719,8 +12719,8 @@
           </a:prstGeom>
           <a:noFill/>
           <a:ln/>
-        </p:spPr>
-        <p:txBody>
+        </ns0:spPr>
+        <ns0:txBody>
           <a:bodyPr wrap="square" lIns="0" tIns="0" rIns="0" bIns="0" rtlCol="0" anchor="ctr"/>
           <a:lstStyle/>
           <a:p>
@@ -12740,15 +12740,15 @@
             </a:r>
             <a:endParaRPr lang="en-US" sz="960" dirty="0"/>
           </a:p>
-        </p:txBody>
-      </p:sp>
-      <p:sp>
-        <p:nvSpPr>
-          <p:cNvPr id="22" name="Shape 20"/>
-          <p:cNvSpPr/>
-          <p:nvPr/>
-        </p:nvSpPr>
-        <p:spPr>
+        </ns0:txBody>
+      </ns0:sp>
+      <ns0:sp>
+        <ns0:nvSpPr>
+          <ns0:cNvPr id="22" name="Shape 20"/>
+          <ns0:cNvSpPr/>
+          <ns0:nvPr/>
+        </ns0:nvSpPr>
+        <ns0:spPr>
           <a:xfrm>
             <a:off x="987552" y="3054096"/>
             <a:ext cx="384048" cy="384048"/>
@@ -12765,15 +12765,15 @@
             </a:solidFill>
             <a:prstDash val="solid"/>
           </a:ln>
-        </p:spPr>
-      </p:sp>
-      <p:sp>
-        <p:nvSpPr>
-          <p:cNvPr id="23" name="Text 21"/>
-          <p:cNvSpPr/>
-          <p:nvPr/>
-        </p:nvSpPr>
-        <p:spPr>
+        </ns0:spPr>
+      </ns0:sp>
+      <ns0:sp>
+        <ns0:nvSpPr>
+          <ns0:cNvPr id="23" name="Text 21"/>
+          <ns0:cNvSpPr/>
+          <ns0:nvPr/>
+        </ns0:nvSpPr>
+        <ns0:spPr>
           <a:xfrm>
             <a:off x="987552" y="3127248"/>
             <a:ext cx="384048" cy="128016"/>
@@ -12783,8 +12783,8 @@
           </a:prstGeom>
           <a:noFill/>
           <a:ln/>
-        </p:spPr>
-        <p:txBody>
+        </ns0:spPr>
+        <ns0:txBody>
           <a:bodyPr wrap="square" lIns="0" tIns="0" rIns="0" bIns="0" rtlCol="0" anchor="ctr"/>
           <a:lstStyle/>
           <a:p>
@@ -12804,15 +12804,15 @@
             </a:r>
             <a:endParaRPr lang="en-US" sz="840" dirty="0"/>
           </a:p>
-        </p:txBody>
-      </p:sp>
-      <p:sp>
-        <p:nvSpPr>
-          <p:cNvPr id="24" name="Text 22"/>
-          <p:cNvSpPr/>
-          <p:nvPr/>
-        </p:nvSpPr>
-        <p:spPr>
+        </ns0:txBody>
+      </ns0:sp>
+      <ns0:sp>
+        <ns0:nvSpPr>
+          <ns0:cNvPr id="24" name="Text 22"/>
+          <ns0:cNvSpPr/>
+          <ns0:nvPr/>
+        </ns0:nvSpPr>
+        <ns0:spPr>
           <a:xfrm>
             <a:off x="1554480" y="3072384"/>
             <a:ext cx="1280160" cy="182880"/>
@@ -12822,8 +12822,8 @@
           </a:prstGeom>
           <a:noFill/>
           <a:ln/>
-        </p:spPr>
-        <p:txBody>
+        </ns0:spPr>
+        <ns0:txBody>
           <a:bodyPr wrap="square" lIns="0" tIns="0" rIns="0" bIns="0" rtlCol="0" anchor="ctr"/>
           <a:lstStyle/>
           <a:p>
@@ -12843,15 +12843,15 @@
             </a:r>
             <a:endParaRPr lang="en-US" sz="1050" dirty="0"/>
           </a:p>
-        </p:txBody>
-      </p:sp>
-      <p:sp>
-        <p:nvSpPr>
-          <p:cNvPr id="25" name="Text 23"/>
-          <p:cNvSpPr/>
-          <p:nvPr/>
-        </p:nvSpPr>
-        <p:spPr>
+        </ns0:txBody>
+      </ns0:sp>
+      <ns0:sp>
+        <ns0:nvSpPr>
+          <ns0:cNvPr id="25" name="Text 23"/>
+          <ns0:cNvSpPr/>
+          <ns0:nvPr/>
+        </ns0:nvSpPr>
+        <ns0:spPr>
           <a:xfrm>
             <a:off x="2816352" y="3081528"/>
             <a:ext cx="7863840" cy="201168"/>
@@ -12861,8 +12861,8 @@
           </a:prstGeom>
           <a:noFill/>
           <a:ln/>
-        </p:spPr>
-        <p:txBody>
+        </ns0:spPr>
+        <ns0:txBody>
           <a:bodyPr wrap="square" lIns="0" tIns="0" rIns="0" bIns="0" rtlCol="0" anchor="ctr"/>
           <a:lstStyle/>
           <a:p>
@@ -12882,15 +12882,15 @@
             </a:r>
             <a:endParaRPr lang="en-US" sz="960" dirty="0"/>
           </a:p>
-        </p:txBody>
-      </p:sp>
-      <p:sp>
-        <p:nvSpPr>
-          <p:cNvPr id="26" name="Shape 24"/>
-          <p:cNvSpPr/>
-          <p:nvPr/>
-        </p:nvSpPr>
-        <p:spPr>
+        </ns0:txBody>
+      </ns0:sp>
+      <ns0:sp>
+        <ns0:nvSpPr>
+          <ns0:cNvPr id="26" name="Shape 24"/>
+          <ns0:cNvSpPr/>
+          <ns0:nvPr/>
+        </ns0:nvSpPr>
+        <ns0:spPr>
           <a:xfrm>
             <a:off x="987552" y="3621024"/>
             <a:ext cx="384048" cy="384048"/>
@@ -12907,15 +12907,15 @@
             </a:solidFill>
             <a:prstDash val="solid"/>
           </a:ln>
-        </p:spPr>
-      </p:sp>
-      <p:sp>
-        <p:nvSpPr>
-          <p:cNvPr id="27" name="Text 25"/>
-          <p:cNvSpPr/>
-          <p:nvPr/>
-        </p:nvSpPr>
-        <p:spPr>
+        </ns0:spPr>
+      </ns0:sp>
+      <ns0:sp>
+        <ns0:nvSpPr>
+          <ns0:cNvPr id="27" name="Text 25"/>
+          <ns0:cNvSpPr/>
+          <ns0:nvPr/>
+        </ns0:nvSpPr>
+        <ns0:spPr>
           <a:xfrm>
             <a:off x="987552" y="3694176"/>
             <a:ext cx="384048" cy="128016"/>
@@ -12925,8 +12925,8 @@
           </a:prstGeom>
           <a:noFill/>
           <a:ln/>
-        </p:spPr>
-        <p:txBody>
+        </ns0:spPr>
+        <ns0:txBody>
           <a:bodyPr wrap="square" lIns="0" tIns="0" rIns="0" bIns="0" rtlCol="0" anchor="ctr"/>
           <a:lstStyle/>
           <a:p>
@@ -12946,15 +12946,15 @@
             </a:r>
             <a:endParaRPr lang="en-US" sz="840" dirty="0"/>
           </a:p>
-        </p:txBody>
-      </p:sp>
-      <p:sp>
-        <p:nvSpPr>
-          <p:cNvPr id="28" name="Text 26"/>
-          <p:cNvSpPr/>
-          <p:nvPr/>
-        </p:nvSpPr>
-        <p:spPr>
+        </ns0:txBody>
+      </ns0:sp>
+      <ns0:sp>
+        <ns0:nvSpPr>
+          <ns0:cNvPr id="28" name="Text 26"/>
+          <ns0:cNvSpPr/>
+          <ns0:nvPr/>
+        </ns0:nvSpPr>
+        <ns0:spPr>
           <a:xfrm>
             <a:off x="1554480" y="3639312"/>
             <a:ext cx="1280160" cy="182880"/>
@@ -12964,8 +12964,8 @@
           </a:prstGeom>
           <a:noFill/>
           <a:ln/>
-        </p:spPr>
-        <p:txBody>
+        </ns0:spPr>
+        <ns0:txBody>
           <a:bodyPr wrap="square" lIns="0" tIns="0" rIns="0" bIns="0" rtlCol="0" anchor="ctr"/>
           <a:lstStyle/>
           <a:p>
@@ -12985,15 +12985,15 @@
             </a:r>
             <a:endParaRPr lang="en-US" sz="1050" dirty="0"/>
           </a:p>
-        </p:txBody>
-      </p:sp>
-      <p:sp>
-        <p:nvSpPr>
-          <p:cNvPr id="29" name="Text 27"/>
-          <p:cNvSpPr/>
-          <p:nvPr/>
-        </p:nvSpPr>
-        <p:spPr>
+        </ns0:txBody>
+      </ns0:sp>
+      <ns0:sp>
+        <ns0:nvSpPr>
+          <ns0:cNvPr id="29" name="Text 27"/>
+          <ns0:cNvSpPr/>
+          <ns0:nvPr/>
+        </ns0:nvSpPr>
+        <ns0:spPr>
           <a:xfrm>
             <a:off x="2816352" y="3648456"/>
             <a:ext cx="7863840" cy="201168"/>
@@ -13003,8 +13003,8 @@
           </a:prstGeom>
           <a:noFill/>
           <a:ln/>
-        </p:spPr>
-        <p:txBody>
+        </ns0:spPr>
+        <ns0:txBody>
           <a:bodyPr wrap="square" lIns="0" tIns="0" rIns="0" bIns="0" rtlCol="0" anchor="ctr"/>
           <a:lstStyle/>
           <a:p>
@@ -13020,19 +13020,19 @@
                 <a:ea typeface="Microsoft YaHei" pitchFamily="34" charset="-122"/>
                 <a:cs typeface="Microsoft YaHei" pitchFamily="34" charset="-120"/>
               </a:rPr>
-              <a:t>调用 result 接口，写 placements 和 metadata</a:t>
+              <a:t>调用 result 接口，写 placements，并读取 network_bindings</a:t>
             </a:r>
             <a:endParaRPr lang="en-US" sz="960" dirty="0"/>
           </a:p>
-        </p:txBody>
-      </p:sp>
-      <p:sp>
-        <p:nvSpPr>
-          <p:cNvPr id="30" name="Shape 28"/>
-          <p:cNvSpPr/>
-          <p:nvPr/>
-        </p:nvSpPr>
-        <p:spPr>
+        </ns0:txBody>
+      </ns0:sp>
+      <ns0:sp>
+        <ns0:nvSpPr>
+          <ns0:cNvPr id="30" name="Shape 28"/>
+          <ns0:cNvSpPr/>
+          <ns0:nvPr/>
+        </ns0:nvSpPr>
+        <ns0:spPr>
           <a:xfrm>
             <a:off x="987552" y="4187952"/>
             <a:ext cx="384048" cy="384048"/>
@@ -13049,15 +13049,15 @@
             </a:solidFill>
             <a:prstDash val="solid"/>
           </a:ln>
-        </p:spPr>
-      </p:sp>
-      <p:sp>
-        <p:nvSpPr>
-          <p:cNvPr id="31" name="Text 29"/>
-          <p:cNvSpPr/>
-          <p:nvPr/>
-        </p:nvSpPr>
-        <p:spPr>
+        </ns0:spPr>
+      </ns0:sp>
+      <ns0:sp>
+        <ns0:nvSpPr>
+          <ns0:cNvPr id="31" name="Text 29"/>
+          <ns0:cNvSpPr/>
+          <ns0:nvPr/>
+        </ns0:nvSpPr>
+        <ns0:spPr>
           <a:xfrm>
             <a:off x="987552" y="4261104"/>
             <a:ext cx="384048" cy="128016"/>
@@ -13067,8 +13067,8 @@
           </a:prstGeom>
           <a:noFill/>
           <a:ln/>
-        </p:spPr>
-        <p:txBody>
+        </ns0:spPr>
+        <ns0:txBody>
           <a:bodyPr wrap="square" lIns="0" tIns="0" rIns="0" bIns="0" rtlCol="0" anchor="ctr"/>
           <a:lstStyle/>
           <a:p>
@@ -13088,15 +13088,15 @@
             </a:r>
             <a:endParaRPr lang="en-US" sz="840" dirty="0"/>
           </a:p>
-        </p:txBody>
-      </p:sp>
-      <p:sp>
-        <p:nvSpPr>
-          <p:cNvPr id="32" name="Text 30"/>
-          <p:cNvSpPr/>
-          <p:nvPr/>
-        </p:nvSpPr>
-        <p:spPr>
+        </ns0:txBody>
+      </ns0:sp>
+      <ns0:sp>
+        <ns0:nvSpPr>
+          <ns0:cNvPr id="32" name="Text 30"/>
+          <ns0:cNvSpPr/>
+          <ns0:nvPr/>
+        </ns0:nvSpPr>
+        <ns0:spPr>
           <a:xfrm>
             <a:off x="1554480" y="4206240"/>
             <a:ext cx="1280160" cy="182880"/>
@@ -13106,8 +13106,8 @@
           </a:prstGeom>
           <a:noFill/>
           <a:ln/>
-        </p:spPr>
-        <p:txBody>
+        </ns0:spPr>
+        <ns0:txBody>
           <a:bodyPr wrap="square" lIns="0" tIns="0" rIns="0" bIns="0" rtlCol="0" anchor="ctr"/>
           <a:lstStyle/>
           <a:p>
@@ -13123,19 +13123,19 @@
                 <a:ea typeface="Microsoft YaHei" pitchFamily="34" charset="-122"/>
                 <a:cs typeface="Microsoft YaHei" pitchFamily="34" charset="-120"/>
               </a:rPr>
-              <a:t>释放</a:t>
+              <a:t>网络</a:t>
             </a:r>
             <a:endParaRPr lang="en-US" sz="1050" dirty="0"/>
           </a:p>
-        </p:txBody>
-      </p:sp>
-      <p:sp>
-        <p:nvSpPr>
-          <p:cNvPr id="33" name="Text 31"/>
-          <p:cNvSpPr/>
-          <p:nvPr/>
-        </p:nvSpPr>
-        <p:spPr>
+        </ns0:txBody>
+      </ns0:sp>
+      <ns0:sp>
+        <ns0:nvSpPr>
+          <ns0:cNvPr id="33" name="Text 31"/>
+          <ns0:cNvSpPr/>
+          <ns0:nvPr/>
+        </ns0:nvSpPr>
+        <ns0:spPr>
           <a:xfrm>
             <a:off x="2816352" y="4215384"/>
             <a:ext cx="7863840" cy="201168"/>
@@ -13145,8 +13145,8 @@
           </a:prstGeom>
           <a:noFill/>
           <a:ln/>
-        </p:spPr>
-        <p:txBody>
+        </ns0:spPr>
+        <ns0:txBody>
           <a:bodyPr wrap="square" lIns="0" tIns="0" rIns="0" bIns="0" rtlCol="0" anchor="ctr"/>
           <a:lstStyle/>
           <a:p>
@@ -13162,19 +13162,19 @@
                 <a:ea typeface="Microsoft YaHei" pitchFamily="34" charset="-122"/>
                 <a:cs typeface="Microsoft YaHei" pitchFamily="34" charset="-120"/>
               </a:rPr>
-              <a:t>读取 release events，加回资源后 ack</a:t>
+              <a:t>下发流表/QoS 后调用 network-ready</a:t>
             </a:r>
             <a:endParaRPr lang="en-US" sz="960" dirty="0"/>
           </a:p>
-        </p:txBody>
-      </p:sp>
-      <p:sp>
-        <p:nvSpPr>
-          <p:cNvPr id="34" name="Shape 32"/>
-          <p:cNvSpPr/>
-          <p:nvPr/>
-        </p:nvSpPr>
-        <p:spPr>
+        </ns0:txBody>
+      </ns0:sp>
+      <ns0:sp>
+        <ns0:nvSpPr>
+          <ns0:cNvPr id="34" name="Shape 32"/>
+          <ns0:cNvSpPr/>
+          <ns0:nvPr/>
+        </ns0:nvSpPr>
+        <ns0:spPr>
           <a:xfrm>
             <a:off x="987552" y="4754880"/>
             <a:ext cx="384048" cy="384048"/>
@@ -13191,15 +13191,15 @@
             </a:solidFill>
             <a:prstDash val="solid"/>
           </a:ln>
-        </p:spPr>
-      </p:sp>
-      <p:sp>
-        <p:nvSpPr>
-          <p:cNvPr id="35" name="Text 33"/>
-          <p:cNvSpPr/>
-          <p:nvPr/>
-        </p:nvSpPr>
-        <p:spPr>
+        </ns0:spPr>
+      </ns0:sp>
+      <ns0:sp>
+        <ns0:nvSpPr>
+          <ns0:cNvPr id="35" name="Text 33"/>
+          <ns0:cNvSpPr/>
+          <ns0:nvPr/>
+        </ns0:nvSpPr>
+        <ns0:spPr>
           <a:xfrm>
             <a:off x="987552" y="4828032"/>
             <a:ext cx="384048" cy="128016"/>
@@ -13209,8 +13209,8 @@
           </a:prstGeom>
           <a:noFill/>
           <a:ln/>
-        </p:spPr>
-        <p:txBody>
+        </ns0:spPr>
+        <ns0:txBody>
           <a:bodyPr wrap="square" lIns="0" tIns="0" rIns="0" bIns="0" rtlCol="0" anchor="ctr"/>
           <a:lstStyle/>
           <a:p>
@@ -13230,15 +13230,15 @@
             </a:r>
             <a:endParaRPr lang="en-US" sz="840" dirty="0"/>
           </a:p>
-        </p:txBody>
-      </p:sp>
-      <p:sp>
-        <p:nvSpPr>
-          <p:cNvPr id="36" name="Text 34"/>
-          <p:cNvSpPr/>
-          <p:nvPr/>
-        </p:nvSpPr>
-        <p:spPr>
+        </ns0:txBody>
+      </ns0:sp>
+      <ns0:sp>
+        <ns0:nvSpPr>
+          <ns0:cNvPr id="36" name="Text 34"/>
+          <ns0:cNvSpPr/>
+          <ns0:nvPr/>
+        </ns0:nvSpPr>
+        <ns0:spPr>
           <a:xfrm>
             <a:off x="1554480" y="4773168"/>
             <a:ext cx="1280160" cy="182880"/>
@@ -13248,8 +13248,8 @@
           </a:prstGeom>
           <a:noFill/>
           <a:ln/>
-        </p:spPr>
-        <p:txBody>
+        </ns0:spPr>
+        <ns0:txBody>
           <a:bodyPr wrap="square" lIns="0" tIns="0" rIns="0" bIns="0" rtlCol="0" anchor="ctr"/>
           <a:lstStyle/>
           <a:p>
@@ -13265,19 +13265,19 @@
                 <a:ea typeface="Microsoft YaHei" pitchFamily="34" charset="-122"/>
                 <a:cs typeface="Microsoft YaHei" pitchFamily="34" charset="-120"/>
               </a:rPr>
-              <a:t>异常</a:t>
+              <a:t>释放/异常</a:t>
             </a:r>
             <a:endParaRPr lang="en-US" sz="1050" dirty="0"/>
           </a:p>
-        </p:txBody>
-      </p:sp>
-      <p:sp>
-        <p:nvSpPr>
-          <p:cNvPr id="37" name="Text 35"/>
-          <p:cNvSpPr/>
-          <p:nvPr/>
-        </p:nvSpPr>
-        <p:spPr>
+        </ns0:txBody>
+      </ns0:sp>
+      <ns0:sp>
+        <ns0:nvSpPr>
+          <ns0:cNvPr id="37" name="Text 35"/>
+          <ns0:cNvSpPr/>
+          <ns0:nvPr/>
+        </ns0:nvSpPr>
+        <ns0:spPr>
           <a:xfrm>
             <a:off x="2816352" y="4782312"/>
             <a:ext cx="7863840" cy="201168"/>
@@ -13287,8 +13287,8 @@
           </a:prstGeom>
           <a:noFill/>
           <a:ln/>
-        </p:spPr>
-        <p:txBody>
+        </ns0:spPr>
+        <ns0:txBody>
           <a:bodyPr wrap="square" lIns="0" tIns="0" rIns="0" bIns="0" rtlCol="0" anchor="ctr"/>
           <a:lstStyle/>
           <a:p>
@@ -13304,19 +13304,19 @@
                 <a:ea typeface="Microsoft YaHei" pitchFamily="34" charset="-122"/>
                 <a:cs typeface="Microsoft YaHei" pitchFamily="34" charset="-120"/>
               </a:rPr>
-              <a:t>资源暂不足 requeue；无法路由 fail；409 冲突撤销扣减</a:t>
+              <a:t>读取 release events 加回资源；资源不足 requeue；409 撤销扣减</a:t>
             </a:r>
             <a:endParaRPr lang="en-US" sz="960" dirty="0"/>
           </a:p>
-        </p:txBody>
-      </p:sp>
-      <p:sp>
-        <p:nvSpPr>
-          <p:cNvPr id="38" name="Shape 36"/>
-          <p:cNvSpPr/>
-          <p:nvPr/>
-        </p:nvSpPr>
-        <p:spPr>
+        </ns0:txBody>
+      </ns0:sp>
+      <ns0:sp>
+        <ns0:nvSpPr>
+          <ns0:cNvPr id="38" name="Shape 36"/>
+          <ns0:cNvSpPr/>
+          <ns0:nvPr/>
+        </ns0:nvSpPr>
+        <ns0:spPr>
           <a:xfrm>
             <a:off x="987552" y="5687568"/>
             <a:ext cx="10012680" cy="384048"/>
@@ -13337,15 +13337,15 @@
             </a:solidFill>
             <a:prstDash val="solid"/>
           </a:ln>
-        </p:spPr>
-      </p:sp>
-      <p:sp>
-        <p:nvSpPr>
-          <p:cNvPr id="39" name="Text 37"/>
-          <p:cNvSpPr/>
-          <p:nvPr/>
-        </p:nvSpPr>
-        <p:spPr>
+        </ns0:spPr>
+      </ns0:sp>
+      <ns0:sp>
+        <ns0:nvSpPr>
+          <ns0:cNvPr id="39" name="Text 37"/>
+          <ns0:cNvSpPr/>
+          <ns0:nvPr/>
+        </ns0:nvSpPr>
+        <ns0:spPr>
           <a:xfrm>
             <a:off x="1060704" y="5788152"/>
             <a:ext cx="9866376" cy="201168"/>
@@ -13355,8 +13355,8 @@
           </a:prstGeom>
           <a:noFill/>
           <a:ln/>
-        </p:spPr>
-        <p:txBody>
+        </ns0:spPr>
+        <ns0:txBody>
           <a:bodyPr wrap="square" lIns="0" tIns="0" rIns="0" bIns="0" rtlCol="0" anchor="ctr"/>
           <a:lstStyle/>
           <a:p>
@@ -13376,14 +13376,14 @@
             </a:r>
             <a:endParaRPr lang="en-US" sz="980" dirty="0"/>
           </a:p>
-        </p:txBody>
-      </p:sp>
-    </p:spTree>
-  </p:cSld>
-  <p:clrMapOvr>
+        </ns0:txBody>
+      </ns0:sp>
+    </ns0:spTree>
+  </ns0:cSld>
+  <ns0:clrMapOvr>
     <a:masterClrMapping/>
-  </p:clrMapOvr>
-</p:sld>
+  </ns0:clrMapOvr>
+</ns0:sld>
 </file>
 
 <file path=ppt/theme/theme1.xml><?xml version="1.0" encoding="utf-8"?>

</xml_diff>